<commit_message>
fix some bug 20250714
</commit_message>
<xml_diff>
--- a/test_fit/parameter_dependency.pptx
+++ b/test_fit/parameter_dependency.pptx
@@ -10,6 +10,7 @@
     <p:sldId id="279" r:id="rId4"/>
     <p:sldId id="280" r:id="rId5"/>
     <p:sldId id="281" r:id="rId6"/>
+    <p:sldId id="282" r:id="rId7"/>
   </p:sldIdLst>
   <p:sldSz cx="12192000" cy="6858000"/>
   <p:notesSz cx="6858000" cy="9144000"/>
@@ -263,7 +264,7 @@
           <a:p>
             <a:fld id="{8DDDD884-4005-48B0-BA66-9591723C410A}" type="datetimeFigureOut">
               <a:rPr lang="zh-TW" altLang="en-US" smtClean="0"/>
-              <a:t>2025/7/11</a:t>
+              <a:t>2025/7/14</a:t>
             </a:fld>
             <a:endParaRPr lang="zh-TW" altLang="en-US"/>
           </a:p>
@@ -461,7 +462,7 @@
           <a:p>
             <a:fld id="{8DDDD884-4005-48B0-BA66-9591723C410A}" type="datetimeFigureOut">
               <a:rPr lang="zh-TW" altLang="en-US" smtClean="0"/>
-              <a:t>2025/7/11</a:t>
+              <a:t>2025/7/14</a:t>
             </a:fld>
             <a:endParaRPr lang="zh-TW" altLang="en-US"/>
           </a:p>
@@ -669,7 +670,7 @@
           <a:p>
             <a:fld id="{8DDDD884-4005-48B0-BA66-9591723C410A}" type="datetimeFigureOut">
               <a:rPr lang="zh-TW" altLang="en-US" smtClean="0"/>
-              <a:t>2025/7/11</a:t>
+              <a:t>2025/7/14</a:t>
             </a:fld>
             <a:endParaRPr lang="zh-TW" altLang="en-US"/>
           </a:p>
@@ -867,7 +868,7 @@
           <a:p>
             <a:fld id="{8DDDD884-4005-48B0-BA66-9591723C410A}" type="datetimeFigureOut">
               <a:rPr lang="zh-TW" altLang="en-US" smtClean="0"/>
-              <a:t>2025/7/11</a:t>
+              <a:t>2025/7/14</a:t>
             </a:fld>
             <a:endParaRPr lang="zh-TW" altLang="en-US"/>
           </a:p>
@@ -1142,7 +1143,7 @@
           <a:p>
             <a:fld id="{8DDDD884-4005-48B0-BA66-9591723C410A}" type="datetimeFigureOut">
               <a:rPr lang="zh-TW" altLang="en-US" smtClean="0"/>
-              <a:t>2025/7/11</a:t>
+              <a:t>2025/7/14</a:t>
             </a:fld>
             <a:endParaRPr lang="zh-TW" altLang="en-US"/>
           </a:p>
@@ -1407,7 +1408,7 @@
           <a:p>
             <a:fld id="{8DDDD884-4005-48B0-BA66-9591723C410A}" type="datetimeFigureOut">
               <a:rPr lang="zh-TW" altLang="en-US" smtClean="0"/>
-              <a:t>2025/7/11</a:t>
+              <a:t>2025/7/14</a:t>
             </a:fld>
             <a:endParaRPr lang="zh-TW" altLang="en-US"/>
           </a:p>
@@ -1819,7 +1820,7 @@
           <a:p>
             <a:fld id="{8DDDD884-4005-48B0-BA66-9591723C410A}" type="datetimeFigureOut">
               <a:rPr lang="zh-TW" altLang="en-US" smtClean="0"/>
-              <a:t>2025/7/11</a:t>
+              <a:t>2025/7/14</a:t>
             </a:fld>
             <a:endParaRPr lang="zh-TW" altLang="en-US"/>
           </a:p>
@@ -1960,7 +1961,7 @@
           <a:p>
             <a:fld id="{8DDDD884-4005-48B0-BA66-9591723C410A}" type="datetimeFigureOut">
               <a:rPr lang="zh-TW" altLang="en-US" smtClean="0"/>
-              <a:t>2025/7/11</a:t>
+              <a:t>2025/7/14</a:t>
             </a:fld>
             <a:endParaRPr lang="zh-TW" altLang="en-US"/>
           </a:p>
@@ -2073,7 +2074,7 @@
           <a:p>
             <a:fld id="{8DDDD884-4005-48B0-BA66-9591723C410A}" type="datetimeFigureOut">
               <a:rPr lang="zh-TW" altLang="en-US" smtClean="0"/>
-              <a:t>2025/7/11</a:t>
+              <a:t>2025/7/14</a:t>
             </a:fld>
             <a:endParaRPr lang="zh-TW" altLang="en-US"/>
           </a:p>
@@ -2384,7 +2385,7 @@
           <a:p>
             <a:fld id="{8DDDD884-4005-48B0-BA66-9591723C410A}" type="datetimeFigureOut">
               <a:rPr lang="zh-TW" altLang="en-US" smtClean="0"/>
-              <a:t>2025/7/11</a:t>
+              <a:t>2025/7/14</a:t>
             </a:fld>
             <a:endParaRPr lang="zh-TW" altLang="en-US"/>
           </a:p>
@@ -2672,7 +2673,7 @@
           <a:p>
             <a:fld id="{8DDDD884-4005-48B0-BA66-9591723C410A}" type="datetimeFigureOut">
               <a:rPr lang="zh-TW" altLang="en-US" smtClean="0"/>
-              <a:t>2025/7/11</a:t>
+              <a:t>2025/7/14</a:t>
             </a:fld>
             <a:endParaRPr lang="zh-TW" altLang="en-US"/>
           </a:p>
@@ -2913,7 +2914,7 @@
           <a:p>
             <a:fld id="{8DDDD884-4005-48B0-BA66-9591723C410A}" type="datetimeFigureOut">
               <a:rPr lang="zh-TW" altLang="en-US" smtClean="0"/>
-              <a:t>2025/7/11</a:t>
+              <a:t>2025/7/14</a:t>
             </a:fld>
             <a:endParaRPr lang="zh-TW" altLang="en-US"/>
           </a:p>
@@ -3348,10 +3349,16 @@
         </p:nvSpPr>
         <p:spPr/>
         <p:txBody>
-          <a:bodyPr/>
+          <a:bodyPr>
+            <a:normAutofit fontScale="90000"/>
+          </a:bodyPr>
           <a:lstStyle/>
           <a:p>
-            <a:endParaRPr lang="zh-TW" altLang="en-US"/>
+            <a:r>
+              <a:rPr lang="en-US" altLang="zh-TW" dirty="0"/>
+              <a:t>Parameter dependency check of couple mode theory in time </a:t>
+            </a:r>
+            <a:endParaRPr lang="zh-TW" altLang="en-US" dirty="0"/>
           </a:p>
         </p:txBody>
       </p:sp>
@@ -3444,8 +3451,8 @@
           </a:p>
         </p:txBody>
       </p:sp>
-      <mc:AlternateContent xmlns:mc="http://schemas.openxmlformats.org/markup-compatibility/2006">
-        <mc:Choice xmlns:a14="http://schemas.microsoft.com/office/drawing/2010/main" Requires="a14">
+      <mc:AlternateContent xmlns:mc="http://schemas.openxmlformats.org/markup-compatibility/2006" xmlns:a14="http://schemas.microsoft.com/office/drawing/2010/main">
+        <mc:Choice Requires="a14">
           <p:sp>
             <p:nvSpPr>
               <p:cNvPr id="4" name="內容版面配置區 3">
@@ -4075,19 +4082,7 @@
                                 <a:rPr lang="en-US" altLang="zh-TW" sz="2000" i="1">
                                   <a:latin typeface="Cambria Math" panose="02040503050406030204" pitchFamily="18" charset="0"/>
                                 </a:rPr>
-                                <m:t>/</m:t>
-                              </m:r>
-                              <m:r>
-                                <a:rPr lang="en-US" altLang="zh-TW" sz="2000" i="1">
-                                  <a:latin typeface="Cambria Math" panose="02040503050406030204" pitchFamily="18" charset="0"/>
-                                </a:rPr>
-                                <m:t>2</m:t>
-                              </m:r>
-                              <m:r>
-                                <a:rPr lang="en-US" altLang="zh-TW" sz="2000" i="1">
-                                  <a:latin typeface="Cambria Math" panose="02040503050406030204" pitchFamily="18" charset="0"/>
-                                </a:rPr>
-                                <m:t>+</m:t>
+                                <m:t>/2+</m:t>
                               </m:r>
                               <m:f>
                                 <m:fPr>
@@ -4394,7 +4389,7 @@
             </p:txBody>
           </p:sp>
         </mc:Choice>
-        <mc:Fallback>
+        <mc:Fallback xmlns="">
           <p:sp>
             <p:nvSpPr>
               <p:cNvPr id="4" name="內容版面配置區 3">
@@ -6968,8 +6963,8 @@
           <a:chExt cx="0" cy="0"/>
         </a:xfrm>
       </p:grpSpPr>
-      <mc:AlternateContent xmlns:mc="http://schemas.openxmlformats.org/markup-compatibility/2006">
-        <mc:Choice xmlns:a14="http://schemas.microsoft.com/office/drawing/2010/main" Requires="a14">
+      <mc:AlternateContent xmlns:mc="http://schemas.openxmlformats.org/markup-compatibility/2006" xmlns:a14="http://schemas.microsoft.com/office/drawing/2010/main">
+        <mc:Choice Requires="a14">
           <p:sp>
             <p:nvSpPr>
               <p:cNvPr id="5" name="文字方塊 4">
@@ -7443,7 +7438,7 @@
             </p:txBody>
           </p:sp>
         </mc:Choice>
-        <mc:Fallback>
+        <mc:Fallback xmlns="">
           <p:sp>
             <p:nvSpPr>
               <p:cNvPr id="5" name="文字方塊 4">
@@ -7492,6 +7487,96 @@
     <p:extLst>
       <p:ext uri="{BB962C8B-B14F-4D97-AF65-F5344CB8AC3E}">
         <p14:creationId xmlns:p14="http://schemas.microsoft.com/office/powerpoint/2010/main" val="1147414919"/>
+      </p:ext>
+    </p:extLst>
+  </p:cSld>
+  <p:clrMapOvr>
+    <a:masterClrMapping/>
+  </p:clrMapOvr>
+</p:sld>
+</file>
+
+<file path=ppt/slides/slide6.xml><?xml version="1.0" encoding="utf-8"?>
+<p:sld xmlns:a="http://schemas.openxmlformats.org/drawingml/2006/main" xmlns:r="http://schemas.openxmlformats.org/officeDocument/2006/relationships" xmlns:p="http://schemas.openxmlformats.org/presentationml/2006/main">
+  <p:cSld>
+    <p:spTree>
+      <p:nvGrpSpPr>
+        <p:cNvPr id="1" name=""/>
+        <p:cNvGrpSpPr/>
+        <p:nvPr/>
+      </p:nvGrpSpPr>
+      <p:grpSpPr>
+        <a:xfrm>
+          <a:off x="0" y="0"/>
+          <a:ext cx="0" cy="0"/>
+          <a:chOff x="0" y="0"/>
+          <a:chExt cx="0" cy="0"/>
+        </a:xfrm>
+      </p:grpSpPr>
+      <p:pic>
+        <p:nvPicPr>
+          <p:cNvPr id="9" name="圖片 8">
+            <a:extLst>
+              <a:ext uri="{FF2B5EF4-FFF2-40B4-BE49-F238E27FC236}">
+                <a16:creationId xmlns:a16="http://schemas.microsoft.com/office/drawing/2014/main" id="{B22BD464-E30B-DE93-491F-F33A0C934F73}"/>
+              </a:ext>
+            </a:extLst>
+          </p:cNvPr>
+          <p:cNvPicPr>
+            <a:picLocks noChangeAspect="1"/>
+          </p:cNvPicPr>
+          <p:nvPr/>
+        </p:nvPicPr>
+        <p:blipFill>
+          <a:blip r:embed="rId2"/>
+          <a:stretch>
+            <a:fillRect/>
+          </a:stretch>
+        </p:blipFill>
+        <p:spPr>
+          <a:xfrm>
+            <a:off x="1" y="1365583"/>
+            <a:ext cx="6096000" cy="4606963"/>
+          </a:xfrm>
+          <a:prstGeom prst="rect">
+            <a:avLst/>
+          </a:prstGeom>
+        </p:spPr>
+      </p:pic>
+      <p:pic>
+        <p:nvPicPr>
+          <p:cNvPr id="11" name="圖片 10">
+            <a:extLst>
+              <a:ext uri="{FF2B5EF4-FFF2-40B4-BE49-F238E27FC236}">
+                <a16:creationId xmlns:a16="http://schemas.microsoft.com/office/drawing/2014/main" id="{CEA6D755-D65D-1C99-B5F6-29C8993A94E5}"/>
+              </a:ext>
+            </a:extLst>
+          </p:cNvPr>
+          <p:cNvPicPr>
+            <a:picLocks noChangeAspect="1"/>
+          </p:cNvPicPr>
+          <p:nvPr/>
+        </p:nvPicPr>
+        <p:blipFill>
+          <a:blip r:embed="rId3"/>
+          <a:stretch>
+            <a:fillRect/>
+          </a:stretch>
+        </p:blipFill>
+        <p:spPr>
+          <a:xfrm>
+            <a:off x="5895975" y="1142812"/>
+            <a:ext cx="6202279" cy="4724750"/>
+          </a:xfrm>
+          <a:prstGeom prst="rect">
+            <a:avLst/>
+          </a:prstGeom>
+        </p:spPr>
+      </p:pic>
+    </p:spTree>
+    <p:extLst>
+      <p:ext uri="{BB962C8B-B14F-4D97-AF65-F5344CB8AC3E}">
+        <p14:creationId xmlns:p14="http://schemas.microsoft.com/office/powerpoint/2010/main" val="3230402140"/>
       </p:ext>
     </p:extLst>
   </p:cSld>

</xml_diff>